<commit_message>
Add ER diagram; refresh report (with ER diagram + populated TOC) and deck
</commit_message>
<xml_diff>
--- a/submission/P19_Team19_Grocery_Delivery_Platform.pptx
+++ b/submission/P19_Team19_Grocery_Delivery_Platform.pptx
@@ -10568,7 +10568,7 @@
                 <a:ea typeface="Calibri" pitchFamily="34" charset="-122"/>
                 <a:cs typeface="Calibri" pitchFamily="34" charset="-120"/>
               </a:rPr>
-              <a:t>SIX COLLECTIONS - EMBED VS. REFERENCE</a:t>
+              <a:t>ENTITY-RELATIONSHIP DIAGRAM - SIX COLLECTIONS, EMBED VS. REFERENCE</a:t>
             </a:r>
             <a:endParaRPr lang="en-US" sz="1200" dirty="0"/>
           </a:p>
@@ -10621,18 +10621,16 @@
         </p:nvSpPr>
         <p:spPr>
           <a:xfrm>
-            <a:off x="868680" y="1828800"/>
-            <a:ext cx="3383280" cy="1737360"/>
-          </a:xfrm>
-          <a:prstGeom prst="roundRect">
-            <a:avLst>
-              <a:gd name="adj" fmla="val 3158"/>
-            </a:avLst>
+            <a:off x="1176376" y="1344168"/>
+            <a:ext cx="9838944" cy="5645767"/>
+          </a:xfrm>
+          <a:prstGeom prst="rect">
+            <a:avLst/>
           </a:prstGeom>
           <a:solidFill>
             <a:srgbClr val="FFFFFF"/>
           </a:solidFill>
-          <a:ln w="19050">
+          <a:ln w="12700">
             <a:solidFill>
               <a:srgbClr val="97BC62"/>
             </a:solidFill>
@@ -10640,906 +10638,30 @@
           </a:ln>
         </p:spPr>
       </p:sp>
-      <p:sp>
-        <p:nvSpPr>
-          <p:cNvPr id="7" name="Shape 5"/>
-          <p:cNvSpPr/>
-          <p:nvPr/>
-        </p:nvSpPr>
-        <p:spPr>
-          <a:xfrm>
-            <a:off x="868680" y="1828800"/>
-            <a:ext cx="3383280" cy="457200"/>
-          </a:xfrm>
-          <a:prstGeom prst="rect">
-            <a:avLst/>
-          </a:prstGeom>
-          <a:solidFill>
-            <a:srgbClr val="2C5F2D"/>
-          </a:solidFill>
-          <a:ln/>
-        </p:spPr>
-      </p:sp>
-      <p:sp>
-        <p:nvSpPr>
-          <p:cNvPr id="8" name="Text 6"/>
-          <p:cNvSpPr/>
-          <p:nvPr/>
-        </p:nvSpPr>
-        <p:spPr>
-          <a:xfrm>
-            <a:off x="868680" y="1828800"/>
-            <a:ext cx="3383280" cy="457200"/>
-          </a:xfrm>
-          <a:prstGeom prst="rect">
-            <a:avLst/>
-          </a:prstGeom>
-          <a:noFill/>
-          <a:ln/>
-        </p:spPr>
-        <p:txBody>
-          <a:bodyPr wrap="square" rtlCol="0" anchor="ctr"/>
-          <a:lstStyle/>
-          <a:p>
-            <a:pPr algn="ctr" indent="0" marL="0">
-              <a:buNone/>
-            </a:pPr>
-            <a:r>
-              <a:rPr lang="en-US" sz="1400" b="1" dirty="0">
-                <a:solidFill>
-                  <a:srgbClr val="FFFFFF"/>
-                </a:solidFill>
-                <a:latin typeface="Consolas" pitchFamily="34" charset="0"/>
-                <a:ea typeface="Consolas" pitchFamily="34" charset="-122"/>
-                <a:cs typeface="Consolas" pitchFamily="34" charset="-120"/>
-              </a:rPr>
-              <a:t>users</a:t>
-            </a:r>
-            <a:endParaRPr lang="en-US" sz="1400" dirty="0"/>
-          </a:p>
-        </p:txBody>
-      </p:sp>
-      <p:sp>
-        <p:nvSpPr>
-          <p:cNvPr id="9" name="Text 7"/>
-          <p:cNvSpPr/>
-          <p:nvPr/>
-        </p:nvSpPr>
-        <p:spPr>
-          <a:xfrm>
-            <a:off x="1033272" y="2340864"/>
-            <a:ext cx="3108960" cy="1170432"/>
-          </a:xfrm>
-          <a:prstGeom prst="rect">
-            <a:avLst/>
-          </a:prstGeom>
-          <a:noFill/>
-          <a:ln/>
-        </p:spPr>
-        <p:txBody>
-          <a:bodyPr wrap="square" rtlCol="0" anchor="ctr"/>
-          <a:lstStyle/>
-          <a:p>
-            <a:pPr indent="0" marL="0">
-              <a:lnSpc>
-                <a:spcPts val="1200"/>
-              </a:lnSpc>
-              <a:buNone/>
-            </a:pPr>
-            <a:r>
-              <a:rPr lang="en-US" sz="900" dirty="0">
-                <a:solidFill>
-                  <a:srgbClr val="1C2B1C"/>
-                </a:solidFill>
-                <a:latin typeface="Consolas" pitchFamily="34" charset="0"/>
-                <a:ea typeface="Consolas" pitchFamily="34" charset="-122"/>
-                <a:cs typeface="Consolas" pitchFamily="34" charset="-120"/>
-              </a:rPr>
-              <a:t>name, email(u), passwordHash,</a:t>
-            </a:r>
-            <a:endParaRPr lang="en-US" sz="900" dirty="0"/>
-          </a:p>
-          <a:p>
-            <a:pPr indent="0" marL="0">
-              <a:lnSpc>
-                <a:spcPts val="1200"/>
-              </a:lnSpc>
-              <a:buNone/>
-            </a:pPr>
-            <a:r>
-              <a:rPr lang="en-US" sz="900" dirty="0">
-                <a:solidFill>
-                  <a:srgbClr val="1C2B1C"/>
-                </a:solidFill>
-                <a:latin typeface="Consolas" pitchFamily="34" charset="0"/>
-                <a:ea typeface="Consolas" pitchFamily="34" charset="-122"/>
-                <a:cs typeface="Consolas" pitchFamily="34" charset="-120"/>
-              </a:rPr>
-              <a:t>role, storeId, addresses[]</a:t>
-            </a:r>
-            <a:endParaRPr lang="en-US" sz="900" dirty="0"/>
-          </a:p>
-        </p:txBody>
-      </p:sp>
-      <p:sp>
-        <p:nvSpPr>
-          <p:cNvPr id="10" name="Shape 8"/>
-          <p:cNvSpPr/>
-          <p:nvPr/>
-        </p:nvSpPr>
-        <p:spPr>
-          <a:xfrm>
-            <a:off x="4480560" y="1828800"/>
-            <a:ext cx="3383280" cy="1737360"/>
-          </a:xfrm>
-          <a:prstGeom prst="roundRect">
-            <a:avLst>
-              <a:gd name="adj" fmla="val 3158"/>
-            </a:avLst>
-          </a:prstGeom>
-          <a:solidFill>
-            <a:srgbClr val="FFFFFF"/>
-          </a:solidFill>
-          <a:ln w="19050">
-            <a:solidFill>
-              <a:srgbClr val="97BC62"/>
-            </a:solidFill>
-            <a:prstDash val="solid"/>
-          </a:ln>
-        </p:spPr>
-      </p:sp>
-      <p:sp>
-        <p:nvSpPr>
-          <p:cNvPr id="11" name="Shape 9"/>
-          <p:cNvSpPr/>
-          <p:nvPr/>
-        </p:nvSpPr>
-        <p:spPr>
-          <a:xfrm>
-            <a:off x="4480560" y="1828800"/>
-            <a:ext cx="3383280" cy="457200"/>
-          </a:xfrm>
-          <a:prstGeom prst="rect">
-            <a:avLst/>
-          </a:prstGeom>
-          <a:solidFill>
-            <a:srgbClr val="2C5F2D"/>
-          </a:solidFill>
-          <a:ln/>
-        </p:spPr>
-      </p:sp>
-      <p:sp>
-        <p:nvSpPr>
-          <p:cNvPr id="12" name="Text 10"/>
-          <p:cNvSpPr/>
-          <p:nvPr/>
-        </p:nvSpPr>
-        <p:spPr>
-          <a:xfrm>
-            <a:off x="4480560" y="1828800"/>
-            <a:ext cx="3383280" cy="457200"/>
-          </a:xfrm>
-          <a:prstGeom prst="rect">
-            <a:avLst/>
-          </a:prstGeom>
-          <a:noFill/>
-          <a:ln/>
-        </p:spPr>
-        <p:txBody>
-          <a:bodyPr wrap="square" rtlCol="0" anchor="ctr"/>
-          <a:lstStyle/>
-          <a:p>
-            <a:pPr algn="ctr" indent="0" marL="0">
-              <a:buNone/>
-            </a:pPr>
-            <a:r>
-              <a:rPr lang="en-US" sz="1400" b="1" dirty="0">
-                <a:solidFill>
-                  <a:srgbClr val="FFFFFF"/>
-                </a:solidFill>
-                <a:latin typeface="Consolas" pitchFamily="34" charset="0"/>
-                <a:ea typeface="Consolas" pitchFamily="34" charset="-122"/>
-                <a:cs typeface="Consolas" pitchFamily="34" charset="-120"/>
-              </a:rPr>
-              <a:t>darkStores</a:t>
-            </a:r>
-            <a:endParaRPr lang="en-US" sz="1400" dirty="0"/>
-          </a:p>
-        </p:txBody>
-      </p:sp>
-      <p:sp>
-        <p:nvSpPr>
-          <p:cNvPr id="13" name="Text 11"/>
-          <p:cNvSpPr/>
-          <p:nvPr/>
-        </p:nvSpPr>
-        <p:spPr>
-          <a:xfrm>
-            <a:off x="4645152" y="2340864"/>
-            <a:ext cx="3108960" cy="1170432"/>
-          </a:xfrm>
-          <a:prstGeom prst="rect">
-            <a:avLst/>
-          </a:prstGeom>
-          <a:noFill/>
-          <a:ln/>
-        </p:spPr>
-        <p:txBody>
-          <a:bodyPr wrap="square" rtlCol="0" anchor="ctr"/>
-          <a:lstStyle/>
-          <a:p>
-            <a:pPr indent="0" marL="0">
-              <a:lnSpc>
-                <a:spcPts val="1200"/>
-              </a:lnSpc>
-              <a:buNone/>
-            </a:pPr>
-            <a:r>
-              <a:rPr lang="en-US" sz="900" dirty="0">
-                <a:solidFill>
-                  <a:srgbClr val="1C2B1C"/>
-                </a:solidFill>
-                <a:latin typeface="Consolas" pitchFamily="34" charset="0"/>
-                <a:ea typeface="Consolas" pitchFamily="34" charset="-122"/>
-                <a:cs typeface="Consolas" pitchFamily="34" charset="-120"/>
-              </a:rPr>
-              <a:t>name(u), area,</a:t>
-            </a:r>
-            <a:endParaRPr lang="en-US" sz="900" dirty="0"/>
-          </a:p>
-          <a:p>
-            <a:pPr indent="0" marL="0">
-              <a:lnSpc>
-                <a:spcPts val="1200"/>
-              </a:lnSpc>
-              <a:buNone/>
-            </a:pPr>
-            <a:r>
-              <a:rPr lang="en-US" sz="900" dirty="0">
-                <a:solidFill>
-                  <a:srgbClr val="1C2B1C"/>
-                </a:solidFill>
-                <a:latin typeface="Consolas" pitchFamily="34" charset="0"/>
-                <a:ea typeface="Consolas" pitchFamily="34" charset="-122"/>
-                <a:cs typeface="Consolas" pitchFamily="34" charset="-120"/>
-              </a:rPr>
-              <a:t>serviceablePincodes[], isActive</a:t>
-            </a:r>
-            <a:endParaRPr lang="en-US" sz="900" dirty="0"/>
-          </a:p>
-        </p:txBody>
-      </p:sp>
-      <p:sp>
-        <p:nvSpPr>
-          <p:cNvPr id="14" name="Shape 12"/>
-          <p:cNvSpPr/>
-          <p:nvPr/>
-        </p:nvSpPr>
-        <p:spPr>
-          <a:xfrm>
-            <a:off x="8092440" y="1828800"/>
-            <a:ext cx="3383280" cy="1737360"/>
-          </a:xfrm>
-          <a:prstGeom prst="roundRect">
-            <a:avLst>
-              <a:gd name="adj" fmla="val 3158"/>
-            </a:avLst>
-          </a:prstGeom>
-          <a:solidFill>
-            <a:srgbClr val="FFFFFF"/>
-          </a:solidFill>
-          <a:ln w="19050">
-            <a:solidFill>
-              <a:srgbClr val="97BC62"/>
-            </a:solidFill>
-            <a:prstDash val="solid"/>
-          </a:ln>
-        </p:spPr>
-      </p:sp>
-      <p:sp>
-        <p:nvSpPr>
-          <p:cNvPr id="15" name="Shape 13"/>
-          <p:cNvSpPr/>
-          <p:nvPr/>
-        </p:nvSpPr>
-        <p:spPr>
-          <a:xfrm>
-            <a:off x="8092440" y="1828800"/>
-            <a:ext cx="3383280" cy="457200"/>
-          </a:xfrm>
-          <a:prstGeom prst="rect">
-            <a:avLst/>
-          </a:prstGeom>
-          <a:solidFill>
-            <a:srgbClr val="2C5F2D"/>
-          </a:solidFill>
-          <a:ln/>
-        </p:spPr>
-      </p:sp>
-      <p:sp>
-        <p:nvSpPr>
-          <p:cNvPr id="16" name="Text 14"/>
-          <p:cNvSpPr/>
-          <p:nvPr/>
-        </p:nvSpPr>
-        <p:spPr>
-          <a:xfrm>
-            <a:off x="8092440" y="1828800"/>
-            <a:ext cx="3383280" cy="457200"/>
-          </a:xfrm>
-          <a:prstGeom prst="rect">
-            <a:avLst/>
-          </a:prstGeom>
-          <a:noFill/>
-          <a:ln/>
-        </p:spPr>
-        <p:txBody>
-          <a:bodyPr wrap="square" rtlCol="0" anchor="ctr"/>
-          <a:lstStyle/>
-          <a:p>
-            <a:pPr algn="ctr" indent="0" marL="0">
-              <a:buNone/>
-            </a:pPr>
-            <a:r>
-              <a:rPr lang="en-US" sz="1400" b="1" dirty="0">
-                <a:solidFill>
-                  <a:srgbClr val="FFFFFF"/>
-                </a:solidFill>
-                <a:latin typeface="Consolas" pitchFamily="34" charset="0"/>
-                <a:ea typeface="Consolas" pitchFamily="34" charset="-122"/>
-                <a:cs typeface="Consolas" pitchFamily="34" charset="-120"/>
-              </a:rPr>
-              <a:t>products</a:t>
-            </a:r>
-            <a:endParaRPr lang="en-US" sz="1400" dirty="0"/>
-          </a:p>
-        </p:txBody>
-      </p:sp>
-      <p:sp>
-        <p:nvSpPr>
-          <p:cNvPr id="17" name="Text 15"/>
-          <p:cNvSpPr/>
-          <p:nvPr/>
-        </p:nvSpPr>
-        <p:spPr>
-          <a:xfrm>
-            <a:off x="8257032" y="2340864"/>
-            <a:ext cx="3108960" cy="1170432"/>
-          </a:xfrm>
-          <a:prstGeom prst="rect">
-            <a:avLst/>
-          </a:prstGeom>
-          <a:noFill/>
-          <a:ln/>
-        </p:spPr>
-        <p:txBody>
-          <a:bodyPr wrap="square" rtlCol="0" anchor="ctr"/>
-          <a:lstStyle/>
-          <a:p>
-            <a:pPr indent="0" marL="0">
-              <a:lnSpc>
-                <a:spcPts val="1200"/>
-              </a:lnSpc>
-              <a:buNone/>
-            </a:pPr>
-            <a:r>
-              <a:rPr lang="en-US" sz="900" dirty="0">
-                <a:solidFill>
-                  <a:srgbClr val="1C2B1C"/>
-                </a:solidFill>
-                <a:latin typeface="Consolas" pitchFamily="34" charset="0"/>
-                <a:ea typeface="Consolas" pitchFamily="34" charset="-122"/>
-                <a:cs typeface="Consolas" pitchFamily="34" charset="-120"/>
-              </a:rPr>
-              <a:t>name, category, unit,</a:t>
-            </a:r>
-            <a:endParaRPr lang="en-US" sz="900" dirty="0"/>
-          </a:p>
-          <a:p>
-            <a:pPr indent="0" marL="0">
-              <a:lnSpc>
-                <a:spcPts val="1200"/>
-              </a:lnSpc>
-              <a:buNone/>
-            </a:pPr>
-            <a:r>
-              <a:rPr lang="en-US" sz="900" dirty="0">
-                <a:solidFill>
-                  <a:srgbClr val="1C2B1C"/>
-                </a:solidFill>
-                <a:latin typeface="Consolas" pitchFamily="34" charset="0"/>
-                <a:ea typeface="Consolas" pitchFamily="34" charset="-122"/>
-                <a:cs typeface="Consolas" pitchFamily="34" charset="-120"/>
-              </a:rPr>
-              <a:t>price, isActive</a:t>
-            </a:r>
-            <a:endParaRPr lang="en-US" sz="900" dirty="0"/>
-          </a:p>
-        </p:txBody>
-      </p:sp>
-      <p:sp>
-        <p:nvSpPr>
-          <p:cNvPr id="18" name="Shape 16"/>
-          <p:cNvSpPr/>
-          <p:nvPr/>
-        </p:nvSpPr>
-        <p:spPr>
-          <a:xfrm>
-            <a:off x="868680" y="3794760"/>
-            <a:ext cx="3383280" cy="1737360"/>
-          </a:xfrm>
-          <a:prstGeom prst="roundRect">
-            <a:avLst>
-              <a:gd name="adj" fmla="val 3158"/>
-            </a:avLst>
-          </a:prstGeom>
-          <a:solidFill>
-            <a:srgbClr val="FFFFFF"/>
-          </a:solidFill>
-          <a:ln w="19050">
-            <a:solidFill>
-              <a:srgbClr val="97BC62"/>
-            </a:solidFill>
-            <a:prstDash val="solid"/>
-          </a:ln>
-        </p:spPr>
-      </p:sp>
-      <p:sp>
-        <p:nvSpPr>
-          <p:cNvPr id="19" name="Shape 17"/>
-          <p:cNvSpPr/>
-          <p:nvPr/>
-        </p:nvSpPr>
-        <p:spPr>
-          <a:xfrm>
-            <a:off x="868680" y="3794760"/>
-            <a:ext cx="3383280" cy="457200"/>
-          </a:xfrm>
-          <a:prstGeom prst="rect">
-            <a:avLst/>
-          </a:prstGeom>
-          <a:solidFill>
-            <a:srgbClr val="2C5F2D"/>
-          </a:solidFill>
-          <a:ln/>
-        </p:spPr>
-      </p:sp>
-      <p:sp>
-        <p:nvSpPr>
-          <p:cNvPr id="20" name="Text 18"/>
-          <p:cNvSpPr/>
-          <p:nvPr/>
-        </p:nvSpPr>
-        <p:spPr>
-          <a:xfrm>
-            <a:off x="868680" y="3794760"/>
-            <a:ext cx="3383280" cy="457200"/>
-          </a:xfrm>
-          <a:prstGeom prst="rect">
-            <a:avLst/>
-          </a:prstGeom>
-          <a:noFill/>
-          <a:ln/>
-        </p:spPr>
-        <p:txBody>
-          <a:bodyPr wrap="square" rtlCol="0" anchor="ctr"/>
-          <a:lstStyle/>
-          <a:p>
-            <a:pPr algn="ctr" indent="0" marL="0">
-              <a:buNone/>
-            </a:pPr>
-            <a:r>
-              <a:rPr lang="en-US" sz="1400" b="1" dirty="0">
-                <a:solidFill>
-                  <a:srgbClr val="FFFFFF"/>
-                </a:solidFill>
-                <a:latin typeface="Consolas" pitchFamily="34" charset="0"/>
-                <a:ea typeface="Consolas" pitchFamily="34" charset="-122"/>
-                <a:cs typeface="Consolas" pitchFamily="34" charset="-120"/>
-              </a:rPr>
-              <a:t>storeStock</a:t>
-            </a:r>
-            <a:endParaRPr lang="en-US" sz="1400" dirty="0"/>
-          </a:p>
-        </p:txBody>
-      </p:sp>
-      <p:sp>
-        <p:nvSpPr>
-          <p:cNvPr id="21" name="Text 19"/>
-          <p:cNvSpPr/>
-          <p:nvPr/>
-        </p:nvSpPr>
-        <p:spPr>
-          <a:xfrm>
-            <a:off x="1033272" y="4306824"/>
-            <a:ext cx="3108960" cy="1170432"/>
-          </a:xfrm>
-          <a:prstGeom prst="rect">
-            <a:avLst/>
-          </a:prstGeom>
-          <a:noFill/>
-          <a:ln/>
-        </p:spPr>
-        <p:txBody>
-          <a:bodyPr wrap="square" rtlCol="0" anchor="ctr"/>
-          <a:lstStyle/>
-          <a:p>
-            <a:pPr indent="0" marL="0">
-              <a:lnSpc>
-                <a:spcPts val="1200"/>
-              </a:lnSpc>
-              <a:buNone/>
-            </a:pPr>
-            <a:r>
-              <a:rPr lang="en-US" sz="900" dirty="0">
-                <a:solidFill>
-                  <a:srgbClr val="1C2B1C"/>
-                </a:solidFill>
-                <a:latin typeface="Consolas" pitchFamily="34" charset="0"/>
-                <a:ea typeface="Consolas" pitchFamily="34" charset="-122"/>
-                <a:cs typeface="Consolas" pitchFamily="34" charset="-120"/>
-              </a:rPr>
-              <a:t>storeId(ref), productId(ref),</a:t>
-            </a:r>
-            <a:endParaRPr lang="en-US" sz="900" dirty="0"/>
-          </a:p>
-          <a:p>
-            <a:pPr indent="0" marL="0">
-              <a:lnSpc>
-                <a:spcPts val="1200"/>
-              </a:lnSpc>
-              <a:buNone/>
-            </a:pPr>
-            <a:r>
-              <a:rPr lang="en-US" sz="900" dirty="0">
-                <a:solidFill>
-                  <a:srgbClr val="1C2B1C"/>
-                </a:solidFill>
-                <a:latin typeface="Consolas" pitchFamily="34" charset="0"/>
-                <a:ea typeface="Consolas" pitchFamily="34" charset="-122"/>
-                <a:cs typeface="Consolas" pitchFamily="34" charset="-120"/>
-              </a:rPr>
-              <a:t>quantity, reorderPoint  [u: store+product]</a:t>
-            </a:r>
-            <a:endParaRPr lang="en-US" sz="900" dirty="0"/>
-          </a:p>
-        </p:txBody>
-      </p:sp>
-      <p:sp>
-        <p:nvSpPr>
-          <p:cNvPr id="22" name="Shape 20"/>
-          <p:cNvSpPr/>
-          <p:nvPr/>
-        </p:nvSpPr>
-        <p:spPr>
-          <a:xfrm>
-            <a:off x="4480560" y="3794760"/>
-            <a:ext cx="3383280" cy="1737360"/>
-          </a:xfrm>
-          <a:prstGeom prst="roundRect">
-            <a:avLst>
-              <a:gd name="adj" fmla="val 3158"/>
-            </a:avLst>
-          </a:prstGeom>
-          <a:solidFill>
-            <a:srgbClr val="FFFFFF"/>
-          </a:solidFill>
-          <a:ln w="19050">
-            <a:solidFill>
-              <a:srgbClr val="97BC62"/>
-            </a:solidFill>
-            <a:prstDash val="solid"/>
-          </a:ln>
-        </p:spPr>
-      </p:sp>
-      <p:sp>
-        <p:nvSpPr>
-          <p:cNvPr id="23" name="Shape 21"/>
-          <p:cNvSpPr/>
-          <p:nvPr/>
-        </p:nvSpPr>
-        <p:spPr>
-          <a:xfrm>
-            <a:off x="4480560" y="3794760"/>
-            <a:ext cx="3383280" cy="457200"/>
-          </a:xfrm>
-          <a:prstGeom prst="rect">
-            <a:avLst/>
-          </a:prstGeom>
-          <a:solidFill>
-            <a:srgbClr val="2C5F2D"/>
-          </a:solidFill>
-          <a:ln/>
-        </p:spPr>
-      </p:sp>
-      <p:sp>
-        <p:nvSpPr>
-          <p:cNvPr id="24" name="Text 22"/>
-          <p:cNvSpPr/>
-          <p:nvPr/>
-        </p:nvSpPr>
-        <p:spPr>
-          <a:xfrm>
-            <a:off x="4480560" y="3794760"/>
-            <a:ext cx="3383280" cy="457200"/>
-          </a:xfrm>
-          <a:prstGeom prst="rect">
-            <a:avLst/>
-          </a:prstGeom>
-          <a:noFill/>
-          <a:ln/>
-        </p:spPr>
-        <p:txBody>
-          <a:bodyPr wrap="square" rtlCol="0" anchor="ctr"/>
-          <a:lstStyle/>
-          <a:p>
-            <a:pPr algn="ctr" indent="0" marL="0">
-              <a:buNone/>
-            </a:pPr>
-            <a:r>
-              <a:rPr lang="en-US" sz="1400" b="1" dirty="0">
-                <a:solidFill>
-                  <a:srgbClr val="FFFFFF"/>
-                </a:solidFill>
-                <a:latin typeface="Consolas" pitchFamily="34" charset="0"/>
-                <a:ea typeface="Consolas" pitchFamily="34" charset="-122"/>
-                <a:cs typeface="Consolas" pitchFamily="34" charset="-120"/>
-              </a:rPr>
-              <a:t>orders</a:t>
-            </a:r>
-            <a:endParaRPr lang="en-US" sz="1400" dirty="0"/>
-          </a:p>
-        </p:txBody>
-      </p:sp>
-      <p:sp>
-        <p:nvSpPr>
-          <p:cNvPr id="25" name="Text 23"/>
-          <p:cNvSpPr/>
-          <p:nvPr/>
-        </p:nvSpPr>
-        <p:spPr>
-          <a:xfrm>
-            <a:off x="4645152" y="4306824"/>
-            <a:ext cx="3108960" cy="1170432"/>
-          </a:xfrm>
-          <a:prstGeom prst="rect">
-            <a:avLst/>
-          </a:prstGeom>
-          <a:noFill/>
-          <a:ln/>
-        </p:spPr>
-        <p:txBody>
-          <a:bodyPr wrap="square" rtlCol="0" anchor="ctr"/>
-          <a:lstStyle/>
-          <a:p>
-            <a:pPr indent="0" marL="0">
-              <a:lnSpc>
-                <a:spcPts val="1200"/>
-              </a:lnSpc>
-              <a:buNone/>
-            </a:pPr>
-            <a:r>
-              <a:rPr lang="en-US" sz="900" dirty="0">
-                <a:solidFill>
-                  <a:srgbClr val="1C2B1C"/>
-                </a:solidFill>
-                <a:latin typeface="Consolas" pitchFamily="34" charset="0"/>
-                <a:ea typeface="Consolas" pitchFamily="34" charset="-122"/>
-                <a:cs typeface="Consolas" pitchFamily="34" charset="-120"/>
-              </a:rPr>
-              <a:t>customerId/storeId/deliveryPartnerId(ref)</a:t>
-            </a:r>
-            <a:endParaRPr lang="en-US" sz="900" dirty="0"/>
-          </a:p>
-          <a:p>
-            <a:pPr indent="0" marL="0">
-              <a:lnSpc>
-                <a:spcPts val="1200"/>
-              </a:lnSpc>
-              <a:buNone/>
-            </a:pPr>
-            <a:r>
-              <a:rPr lang="en-US" sz="900" dirty="0">
-                <a:solidFill>
-                  <a:srgbClr val="1C2B1C"/>
-                </a:solidFill>
-                <a:latin typeface="Consolas" pitchFamily="34" charset="0"/>
-                <a:ea typeface="Consolas" pitchFamily="34" charset="-122"/>
-                <a:cs typeface="Consolas" pitchFamily="34" charset="-120"/>
-              </a:rPr>
-              <a:t>items[]  pricing  deliverySlot  statusHistory[]</a:t>
-            </a:r>
-            <a:endParaRPr lang="en-US" sz="900" dirty="0"/>
-          </a:p>
-        </p:txBody>
-      </p:sp>
-      <p:sp>
-        <p:nvSpPr>
-          <p:cNvPr id="26" name="Shape 24"/>
-          <p:cNvSpPr/>
-          <p:nvPr/>
-        </p:nvSpPr>
-        <p:spPr>
-          <a:xfrm>
-            <a:off x="8092440" y="3794760"/>
-            <a:ext cx="3383280" cy="1737360"/>
-          </a:xfrm>
-          <a:prstGeom prst="roundRect">
-            <a:avLst>
-              <a:gd name="adj" fmla="val 3158"/>
-            </a:avLst>
-          </a:prstGeom>
-          <a:solidFill>
-            <a:srgbClr val="FFFFFF"/>
-          </a:solidFill>
-          <a:ln w="19050">
-            <a:solidFill>
-              <a:srgbClr val="97BC62"/>
-            </a:solidFill>
-            <a:prstDash val="solid"/>
-          </a:ln>
-        </p:spPr>
-      </p:sp>
-      <p:sp>
-        <p:nvSpPr>
-          <p:cNvPr id="27" name="Shape 25"/>
-          <p:cNvSpPr/>
-          <p:nvPr/>
-        </p:nvSpPr>
-        <p:spPr>
-          <a:xfrm>
-            <a:off x="8092440" y="3794760"/>
-            <a:ext cx="3383280" cy="457200"/>
-          </a:xfrm>
-          <a:prstGeom prst="rect">
-            <a:avLst/>
-          </a:prstGeom>
-          <a:solidFill>
-            <a:srgbClr val="2C5F2D"/>
-          </a:solidFill>
-          <a:ln/>
-        </p:spPr>
-      </p:sp>
-      <p:sp>
-        <p:nvSpPr>
-          <p:cNvPr id="28" name="Text 26"/>
-          <p:cNvSpPr/>
-          <p:nvPr/>
-        </p:nvSpPr>
-        <p:spPr>
-          <a:xfrm>
-            <a:off x="8092440" y="3794760"/>
-            <a:ext cx="3383280" cy="457200"/>
-          </a:xfrm>
-          <a:prstGeom prst="rect">
-            <a:avLst/>
-          </a:prstGeom>
-          <a:noFill/>
-          <a:ln/>
-        </p:spPr>
-        <p:txBody>
-          <a:bodyPr wrap="square" rtlCol="0" anchor="ctr"/>
-          <a:lstStyle/>
-          <a:p>
-            <a:pPr algn="ctr" indent="0" marL="0">
-              <a:buNone/>
-            </a:pPr>
-            <a:r>
-              <a:rPr lang="en-US" sz="1400" b="1" dirty="0">
-                <a:solidFill>
-                  <a:srgbClr val="FFFFFF"/>
-                </a:solidFill>
-                <a:latin typeface="Consolas" pitchFamily="34" charset="0"/>
-                <a:ea typeface="Consolas" pitchFamily="34" charset="-122"/>
-                <a:cs typeface="Consolas" pitchFamily="34" charset="-120"/>
-              </a:rPr>
-              <a:t>deliveryPartners</a:t>
-            </a:r>
-            <a:endParaRPr lang="en-US" sz="1400" dirty="0"/>
-          </a:p>
-        </p:txBody>
-      </p:sp>
-      <p:sp>
-        <p:nvSpPr>
-          <p:cNvPr id="29" name="Text 27"/>
-          <p:cNvSpPr/>
-          <p:nvPr/>
-        </p:nvSpPr>
-        <p:spPr>
-          <a:xfrm>
-            <a:off x="8257032" y="4306824"/>
-            <a:ext cx="3108960" cy="1170432"/>
-          </a:xfrm>
-          <a:prstGeom prst="rect">
-            <a:avLst/>
-          </a:prstGeom>
-          <a:noFill/>
-          <a:ln/>
-        </p:spPr>
-        <p:txBody>
-          <a:bodyPr wrap="square" rtlCol="0" anchor="ctr"/>
-          <a:lstStyle/>
-          <a:p>
-            <a:pPr indent="0" marL="0">
-              <a:lnSpc>
-                <a:spcPts val="1200"/>
-              </a:lnSpc>
-              <a:buNone/>
-            </a:pPr>
-            <a:r>
-              <a:rPr lang="en-US" sz="900" dirty="0">
-                <a:solidFill>
-                  <a:srgbClr val="1C2B1C"/>
-                </a:solidFill>
-                <a:latin typeface="Consolas" pitchFamily="34" charset="0"/>
-                <a:ea typeface="Consolas" pitchFamily="34" charset="-122"/>
-                <a:cs typeface="Consolas" pitchFamily="34" charset="-120"/>
-              </a:rPr>
-              <a:t>userId(ref,u), vehicleType,</a:t>
-            </a:r>
-            <a:endParaRPr lang="en-US" sz="900" dirty="0"/>
-          </a:p>
-          <a:p>
-            <a:pPr indent="0" marL="0">
-              <a:lnSpc>
-                <a:spcPts val="1200"/>
-              </a:lnSpc>
-              <a:buNone/>
-            </a:pPr>
-            <a:r>
-              <a:rPr lang="en-US" sz="900" dirty="0">
-                <a:solidFill>
-                  <a:srgbClr val="1C2B1C"/>
-                </a:solidFill>
-                <a:latin typeface="Consolas" pitchFamily="34" charset="0"/>
-                <a:ea typeface="Consolas" pitchFamily="34" charset="-122"/>
-                <a:cs typeface="Consolas" pitchFamily="34" charset="-120"/>
-              </a:rPr>
-              <a:t>isAvailable, currentStoreId(ref)</a:t>
-            </a:r>
-            <a:endParaRPr lang="en-US" sz="900" dirty="0"/>
-          </a:p>
-        </p:txBody>
-      </p:sp>
-      <p:sp>
-        <p:nvSpPr>
-          <p:cNvPr id="30" name="Text 28"/>
-          <p:cNvSpPr/>
-          <p:nvPr/>
-        </p:nvSpPr>
-        <p:spPr>
-          <a:xfrm>
-            <a:off x="868680" y="5806440"/>
-            <a:ext cx="10607040" cy="457200"/>
-          </a:xfrm>
-          <a:prstGeom prst="rect">
-            <a:avLst/>
-          </a:prstGeom>
-          <a:noFill/>
-          <a:ln/>
-        </p:spPr>
-        <p:txBody>
-          <a:bodyPr wrap="square" rtlCol="0" anchor="ctr"/>
-          <a:lstStyle/>
-          <a:p>
-            <a:pPr indent="0" marL="0">
-              <a:buNone/>
-            </a:pPr>
-            <a:r>
-              <a:rPr lang="en-US" sz="1050" i="1" dirty="0">
-                <a:solidFill>
-                  <a:srgbClr val="5B6B5B"/>
-                </a:solidFill>
-                <a:latin typeface="Calibri" pitchFamily="34" charset="0"/>
-                <a:ea typeface="Calibri" pitchFamily="34" charset="-122"/>
-                <a:cs typeface="Calibri" pitchFamily="34" charset="-120"/>
-              </a:rPr>
-              <a:t>ref = referenced by ObjectId   -   u = unique index   -   orders embeds items[] / pricing / deliverySlot / statusHistory[] as a frozen snapshot</a:t>
-            </a:r>
-            <a:endParaRPr lang="en-US" sz="1050" dirty="0"/>
-          </a:p>
-        </p:txBody>
-      </p:sp>
+      <p:pic>
+        <p:nvPicPr>
+          <p:cNvPr id="7" name="Image 0" descr="C:\Users\aaary\AppData\Local\Temp\claude\D--Frontend-5th-sem-CIA-3\d57102eb-a01a-4df8-b483-42b45f88122b\scratchpad\shots-sm\er-diagram.jpg">    </p:cNvPr>
+          <p:cNvPicPr>
+            <a:picLocks noChangeAspect="1"/>
+          </p:cNvPicPr>
+          <p:nvPr/>
+        </p:nvPicPr>
+        <p:blipFill>
+          <a:blip r:embed="rId1"/>
+          <a:stretch>
+            <a:fillRect/>
+          </a:stretch>
+        </p:blipFill>
+        <p:spPr>
+          <a:xfrm>
+            <a:off x="1203808" y="1371600"/>
+            <a:ext cx="9784080" cy="5590903"/>
+          </a:xfrm>
+          <a:prstGeom prst="rect">
+            <a:avLst/>
+          </a:prstGeom>
+        </p:spPr>
+      </p:pic>
     </p:spTree>
   </p:cSld>
   <p:clrMapOvr>

</xml_diff>